<commit_message>
AV v8: apply 27 confirmed review findings, R58 theme fix, coupon numbers from G-code
- engine: coupon inspector crash, hash restore clamps + stale-phase guard, x-ray/wire
  reset on phase change, caliper off when other measure tools start, mouse-only tooltips,
  state() exposes pan/ortho, screwFly tracks the seat point; R58 null-safe theme toggle
- calc_v8: NaN/inf safe, stack-up FAIL when worst case and RSS both miss, tau_dyn T fix
- CAD/slice: DFM counts failed booleans as FAIL; slice.py slices the hole coupon;
  make_config reads coupon grams/minutes from its G-code, digit-free hole labels
- verifier: motion vs calc 2 loads x 3 angles, LOD placement, camera pan/ortho restore,
  screw side vectors, DATAVIZ from the page's ramp, exports must exist
- rebuilt demo, coupon, floor, refs, vercel copy, deck; docs updated

Co-Authored-By: Claude Opus 5.5 <noreply@anthropic.com>
Claude-Session: https://claude.ai/code/session_015TiuMNVcJGucZKHjohAHfr
</commit_message>
<xml_diff>
--- a/sp_av_v6_bundle/media_v8/AV_v8_demo_deck.pptx
+++ b/sp_av_v6_bundle/media_v8/AV_v8_demo_deck.pptx
@@ -111,27 +111,27 @@
   <p:extLst>
     <p:ext uri="{521415D9-36F7-43E2-AB2F-B90AF26B5E84}">
       <p14:sectionLst xmlns:p14="http://schemas.microsoft.com/office/powerpoint/2010/main">
-        <p14:section name="AV v8" id="{626cf5f2-c53f-dfbf-564c-891b0ea23950}">
+        <p14:section name="AV v8" id="{7162fc29-4b6a-5989-90eb-e27adc09c266}">
           <p14:sldIdLst>
             <p14:sldId id="256"/>
           </p14:sldIdLst>
         </p14:section>
-        <p14:section name="Phases" id="{f9ef23bc-f308-cb02-8c49-5cfd9da64051}">
+        <p14:section name="Phases" id="{cb7bd8a3-c76e-32a2-262d-9a6733cdafd8}">
           <p14:sldIdLst>
             <p14:sldId id="257"/>
           </p14:sldIdLst>
         </p14:section>
-        <p14:section name="Physics" id="{7eb61782-cc38-b658-e396-43e0cf0d31eb}">
+        <p14:section name="Physics" id="{10731b0f-6814-49a8-f426-7d5617c2ea29}">
           <p14:sldIdLst>
             <p14:sldId id="258"/>
           </p14:sldIdLst>
         </p14:section>
-        <p14:section name="Findings" id="{9cdc3339-aef5-f180-7b91-5c90147b7775}">
+        <p14:section name="Findings" id="{0e809b3d-f168-d349-c61b-b864db954dca}">
           <p14:sldIdLst>
             <p14:sldId id="259"/>
           </p14:sldIdLst>
         </p14:section>
-        <p14:section name="Next" id="{22190048-089f-f0cb-91bf-a0dc8b57a568}">
+        <p14:section name="Next" id="{dff85c70-6147-0114-93d1-9b28d34ddb60}">
           <p14:sldIdLst>
             <p14:sldId id="260"/>
           </p14:sldIdLst>
@@ -3587,7 +3587,7 @@
                   <a:srgbClr val="8A8F98"/>
                 </a:solidFill>
               </a:rPr>
-              <a:t>12 UNVERIFIED tiles turn PASS or FAIL — both are useful.</a:t>
+              <a:t>11 UNVERIFIED tiles turn PASS or FAIL — both are useful.</a:t>
             </a:r>
             <a:endParaRPr lang="en-US" sz="1200" dirty="0"/>
           </a:p>

</xml_diff>